<commit_message>
Add prompt comparison results to report and presentation
</commit_message>
<xml_diff>
--- a/docs/presentation/Lexicon_Presentation.pptx
+++ b/docs/presentation/Lexicon_Presentation.pptx
@@ -4,9 +4,6 @@
   <p:sldMasterIdLst>
     <p:sldMasterId id="2147483648" r:id="rId1"/>
   </p:sldMasterIdLst>
-  <p:notesMasterIdLst>
-    <p:notesMasterId r:id="rId9"/>
-  </p:notesMasterIdLst>
   <p:sldIdLst>
     <p:sldId id="256" r:id="rId2"/>
     <p:sldId id="257" r:id="rId3"/>
@@ -16,7 +13,10 @@
     <p:sldId id="261" r:id="rId7"/>
     <p:sldId id="262" r:id="rId8"/>
   </p:sldIdLst>
-  <p:sldSz cx="9144000" cy="5143500" type="screen16x9"/>
+  <p:notesMasterIdLst>
+    <p:notesMasterId r:id="rId9"/>
+  </p:notesMasterIdLst>
+  <p:sldSz cx="9144000" cy="5143500"/>
   <p:notesSz cx="5143500" cy="9144000"/>
   <p:defaultTextStyle>
     <a:lvl1pPr marL="0" algn="l" defTabSz="914400" rtl="0" eaLnBrk="1" latinLnBrk="0" hangingPunct="1">
@@ -110,11 +110,6 @@
       </a:defRPr>
     </a:lvl9pPr>
   </p:defaultTextStyle>
-  <p:extLst>
-    <p:ext uri="{EFAFB233-063F-42B5-8137-9DF3F51BA10A}">
-      <p15:sldGuideLst xmlns:p15="http://schemas.microsoft.com/office/powerpoint/2012/main"/>
-    </p:ext>
-  </p:extLst>
 </p:presentation>
 </file>
 
@@ -140,10 +135,234 @@
           <a:chExt cx="0" cy="0"/>
         </a:xfrm>
       </p:grpSpPr>
+      <p:sp>
+        <p:nvSpPr>
+          <p:cNvPr id="2" name="Header Placeholder 1"/>
+          <p:cNvSpPr>
+            <a:spLocks noGrp="1"/>
+          </p:cNvSpPr>
+          <p:nvPr>
+            <p:ph type="hdr" sz="quarter"/>
+          </p:nvPr>
+        </p:nvSpPr>
+        <p:spPr>
+          <a:xfrm>
+            <a:off x="0" y="0"/>
+            <a:ext cx="2971800" cy="458788"/>
+          </a:xfrm>
+          <a:prstGeom prst="rect">
+            <a:avLst/>
+          </a:prstGeom>
+        </p:spPr>
+        <p:txBody>
+          <a:bodyPr vert="horz" lIns="91440" tIns="45720" rIns="91440" bIns="45720" rtlCol="0"/>
+          <a:lstStyle>
+            <a:lvl1pPr algn="l">
+              <a:defRPr sz="1200"/>
+            </a:lvl1pPr>
+          </a:lstStyle>
+          <a:p>
+            <a:endParaRPr lang="en-US"/>
+          </a:p>
+        </p:txBody>
+      </p:sp>
+      <p:sp>
+        <p:nvSpPr>
+          <p:cNvPr id="3" name="Date Placeholder 2"/>
+          <p:cNvSpPr>
+            <a:spLocks noGrp="1"/>
+          </p:cNvSpPr>
+          <p:nvPr>
+            <p:ph type="dt" idx="1"/>
+          </p:nvPr>
+        </p:nvSpPr>
+        <p:spPr>
+          <a:xfrm>
+            <a:off x="3884613" y="0"/>
+            <a:ext cx="2971800" cy="458788"/>
+          </a:xfrm>
+          <a:prstGeom prst="rect">
+            <a:avLst/>
+          </a:prstGeom>
+        </p:spPr>
+        <p:txBody>
+          <a:bodyPr vert="horz" lIns="91440" tIns="45720" rIns="91440" bIns="45720" rtlCol="0"/>
+          <a:lstStyle>
+            <a:lvl1pPr algn="r">
+              <a:defRPr sz="1200"/>
+            </a:lvl1pPr>
+          </a:lstStyle>
+          <a:p>
+            <a:fld id="{5282F153-3F37-0F45-9E97-73ACFA13230C}" type="datetimeFigureOut">
+              <a:rPr lang="en-US"/>
+              <a:t>7/23/19</a:t>
+            </a:fld>
+            <a:endParaRPr lang="en-US"/>
+          </a:p>
+        </p:txBody>
+      </p:sp>
+      <p:sp>
+        <p:nvSpPr>
+          <p:cNvPr id="4" name="Slide Image Placeholder 3"/>
+          <p:cNvSpPr>
+            <a:spLocks noGrp="1" noRot="1" noChangeAspect="1"/>
+          </p:cNvSpPr>
+          <p:nvPr>
+            <p:ph type="sldImg" idx="2"/>
+          </p:nvPr>
+        </p:nvSpPr>
+        <p:spPr>
+          <a:xfrm>
+            <a:off x="685800" y="1143000"/>
+            <a:ext cx="5486400" cy="3086100"/>
+          </a:xfrm>
+          <a:prstGeom prst="rect">
+            <a:avLst/>
+          </a:prstGeom>
+          <a:noFill/>
+          <a:ln w="12700">
+            <a:solidFill>
+              <a:prstClr val="black"/>
+            </a:solidFill>
+          </a:ln>
+        </p:spPr>
+        <p:txBody>
+          <a:bodyPr vert="horz" lIns="91440" tIns="45720" rIns="91440" bIns="45720" rtlCol="0" anchor="ctr"/>
+          <a:lstStyle/>
+          <a:p>
+            <a:endParaRPr lang="en-US"/>
+          </a:p>
+        </p:txBody>
+      </p:sp>
+      <p:sp>
+        <p:nvSpPr>
+          <p:cNvPr id="5" name="Notes Placeholder 4"/>
+          <p:cNvSpPr>
+            <a:spLocks noGrp="1"/>
+          </p:cNvSpPr>
+          <p:nvPr>
+            <p:ph type="body" sz="quarter" idx="3"/>
+          </p:nvPr>
+        </p:nvSpPr>
+        <p:spPr>
+          <a:xfrm>
+            <a:off x="685800" y="4400550"/>
+            <a:ext cx="5486400" cy="3600450"/>
+          </a:xfrm>
+          <a:prstGeom prst="rect">
+            <a:avLst/>
+          </a:prstGeom>
+        </p:spPr>
+        <p:txBody>
+          <a:bodyPr vert="horz" lIns="91440" tIns="45720" rIns="91440" bIns="45720" rtlCol="0"/>
+          <a:lstStyle/>
+          <a:p>
+            <a:pPr lvl="0"/>
+            <a:r>
+              <a:rPr lang="en-US"/>
+              <a:t>Click to edit Master text styles</a:t>
+            </a:r>
+          </a:p>
+          <a:p>
+            <a:pPr lvl="1"/>
+            <a:r>
+              <a:rPr lang="en-US"/>
+              <a:t>Second level</a:t>
+            </a:r>
+          </a:p>
+          <a:p>
+            <a:pPr lvl="2"/>
+            <a:r>
+              <a:rPr lang="en-US"/>
+              <a:t>Third level</a:t>
+            </a:r>
+          </a:p>
+          <a:p>
+            <a:pPr lvl="3"/>
+            <a:r>
+              <a:rPr lang="en-US"/>
+              <a:t>Fourth level</a:t>
+            </a:r>
+          </a:p>
+          <a:p>
+            <a:pPr lvl="4"/>
+            <a:r>
+              <a:rPr lang="en-US"/>
+              <a:t>Fifth level</a:t>
+            </a:r>
+          </a:p>
+        </p:txBody>
+      </p:sp>
+      <p:sp>
+        <p:nvSpPr>
+          <p:cNvPr id="6" name="Footer Placeholder 5"/>
+          <p:cNvSpPr>
+            <a:spLocks noGrp="1"/>
+          </p:cNvSpPr>
+          <p:nvPr>
+            <p:ph type="ftr" sz="quarter" idx="4"/>
+          </p:nvPr>
+        </p:nvSpPr>
+        <p:spPr>
+          <a:xfrm>
+            <a:off x="0" y="8685213"/>
+            <a:ext cx="2971800" cy="458787"/>
+          </a:xfrm>
+          <a:prstGeom prst="rect">
+            <a:avLst/>
+          </a:prstGeom>
+        </p:spPr>
+        <p:txBody>
+          <a:bodyPr vert="horz" lIns="91440" tIns="45720" rIns="91440" bIns="45720" rtlCol="0" anchor="b"/>
+          <a:lstStyle>
+            <a:lvl1pPr algn="l">
+              <a:defRPr sz="1200"/>
+            </a:lvl1pPr>
+          </a:lstStyle>
+          <a:p>
+            <a:endParaRPr lang="en-US"/>
+          </a:p>
+        </p:txBody>
+      </p:sp>
+      <p:sp>
+        <p:nvSpPr>
+          <p:cNvPr id="7" name="Slide Number Placeholder 6"/>
+          <p:cNvSpPr>
+            <a:spLocks noGrp="1"/>
+          </p:cNvSpPr>
+          <p:nvPr>
+            <p:ph type="sldNum" sz="quarter" idx="5"/>
+          </p:nvPr>
+        </p:nvSpPr>
+        <p:spPr>
+          <a:xfrm>
+            <a:off x="3884613" y="8685213"/>
+            <a:ext cx="2971800" cy="458787"/>
+          </a:xfrm>
+          <a:prstGeom prst="rect">
+            <a:avLst/>
+          </a:prstGeom>
+        </p:spPr>
+        <p:txBody>
+          <a:bodyPr vert="horz" lIns="91440" tIns="45720" rIns="91440" bIns="45720" rtlCol="0" anchor="b"/>
+          <a:lstStyle>
+            <a:lvl1pPr algn="r">
+              <a:defRPr sz="1200"/>
+            </a:lvl1pPr>
+          </a:lstStyle>
+          <a:p>
+            <a:fld id="{CE5E9CC1-C706-0F49-92D6-E571CC5EEA8F}" type="slidenum">
+              <a:rPr lang="en-US"/>
+              <a:t>‹#›</a:t>
+            </a:fld>
+            <a:endParaRPr lang="en-US"/>
+          </a:p>
+        </p:txBody>
+      </p:sp>
     </p:spTree>
     <p:extLst>
       <p:ext uri="{BB962C8B-B14F-4D97-AF65-F5344CB8AC3E}">
-        <p14:creationId xmlns:p14="http://schemas.microsoft.com/office/powerpoint/2010/main" val="3237923159"/>
+        <p14:creationId xmlns:p14="http://schemas.microsoft.com/office/powerpoint/2010/main" val="1024086991"/>
       </p:ext>
     </p:extLst>
   </p:cSld>
@@ -291,6 +510,7 @@
               <a:rPr lang="en-US" dirty="0"/>
               <a:t>Introduce Lexicon: upload documents, ask questions, answers grounded in retrieved text.</a:t>
             </a:r>
+            <a:endParaRPr lang="en-US" dirty="0"/>
           </a:p>
         </p:txBody>
       </p:sp>
@@ -374,6 +594,10 @@
           <a:bodyPr/>
           <a:lstStyle/>
           <a:p>
+            <a:r>
+              <a:rPr lang="en-US" dirty="0"/>
+              <a:t/>
+            </a:r>
             <a:endParaRPr lang="en-US" dirty="0"/>
           </a:p>
         </p:txBody>
@@ -458,6 +682,10 @@
           <a:bodyPr/>
           <a:lstStyle/>
           <a:p>
+            <a:r>
+              <a:rPr lang="en-US" dirty="0"/>
+              <a:t/>
+            </a:r>
             <a:endParaRPr lang="en-US" dirty="0"/>
           </a:p>
         </p:txBody>
@@ -542,6 +770,10 @@
           <a:bodyPr/>
           <a:lstStyle/>
           <a:p>
+            <a:r>
+              <a:rPr lang="en-US" dirty="0"/>
+              <a:t/>
+            </a:r>
             <a:endParaRPr lang="en-US" dirty="0"/>
           </a:p>
         </p:txBody>
@@ -626,6 +858,10 @@
           <a:bodyPr/>
           <a:lstStyle/>
           <a:p>
+            <a:r>
+              <a:rPr lang="en-US" dirty="0"/>
+              <a:t/>
+            </a:r>
             <a:endParaRPr lang="en-US" dirty="0"/>
           </a:p>
         </p:txBody>
@@ -710,6 +946,10 @@
           <a:bodyPr/>
           <a:lstStyle/>
           <a:p>
+            <a:r>
+              <a:rPr lang="en-US" dirty="0"/>
+              <a:t/>
+            </a:r>
             <a:endParaRPr lang="en-US" dirty="0"/>
           </a:p>
         </p:txBody>
@@ -794,6 +1034,10 @@
           <a:bodyPr/>
           <a:lstStyle/>
           <a:p>
+            <a:r>
+              <a:rPr lang="en-US" dirty="0"/>
+              <a:t/>
+            </a:r>
             <a:endParaRPr lang="en-US" dirty="0"/>
           </a:p>
         </p:txBody>
@@ -924,11 +1168,9 @@
       <p:sp>
         <p:nvSpPr>
           <p:cNvPr id="4" name="Text 2"/>
-          <p:cNvSpPr>
-            <a:spLocks noGrp="1"/>
-          </p:cNvSpPr>
+          <p:cNvSpPr/>
           <p:nvPr>
-            <p:ph type="title" idx="102" hasCustomPrompt="1"/>
+            <p:ph idx="102" type="title" hasCustomPrompt="1"/>
           </p:nvPr>
         </p:nvSpPr>
         <p:spPr>
@@ -945,7 +1187,7 @@
         <p:txBody>
           <a:bodyPr wrap="square" rtlCol="0"/>
           <a:lstStyle>
-            <a:lvl1pPr marL="0" indent="0">
+            <a:lvl1pPr indent="0" marL="0">
               <a:buNone/>
               <a:defRPr lang="en-US" sz="4400" b="1" dirty="0">
                 <a:solidFill>
@@ -955,7 +1197,7 @@
             </a:lvl1pPr>
           </a:lstStyle>
           <a:p>
-            <a:pPr marL="0" indent="0">
+            <a:pPr indent="0" marL="0">
               <a:buNone/>
             </a:pPr>
             <a:endParaRPr lang="en-US" sz="4400" dirty="0"/>
@@ -965,11 +1207,9 @@
       <p:sp>
         <p:nvSpPr>
           <p:cNvPr id="5" name="Text 2"/>
-          <p:cNvSpPr>
-            <a:spLocks noGrp="1"/>
-          </p:cNvSpPr>
+          <p:cNvSpPr/>
           <p:nvPr>
-            <p:ph type="body" idx="103" hasCustomPrompt="1"/>
+            <p:ph idx="103" type="body" hasCustomPrompt="1"/>
           </p:nvPr>
         </p:nvSpPr>
         <p:spPr>
@@ -986,7 +1226,7 @@
         <p:txBody>
           <a:bodyPr wrap="square" rtlCol="0"/>
           <a:lstStyle>
-            <a:lvl1pPr marL="0" indent="0">
+            <a:lvl1pPr indent="0" marL="0">
               <a:buNone/>
               <a:defRPr lang="en-US" sz="1600" dirty="0">
                 <a:solidFill>
@@ -996,7 +1236,7 @@
             </a:lvl1pPr>
           </a:lstStyle>
           <a:p>
-            <a:pPr marL="0" indent="0">
+            <a:pPr indent="0" marL="0">
               <a:buNone/>
             </a:pPr>
             <a:endParaRPr lang="en-US" sz="1600" dirty="0"/>
@@ -1071,11 +1311,9 @@
       <p:sp>
         <p:nvSpPr>
           <p:cNvPr id="4" name="Text 2"/>
-          <p:cNvSpPr>
-            <a:spLocks noGrp="1"/>
-          </p:cNvSpPr>
+          <p:cNvSpPr/>
           <p:nvPr>
-            <p:ph type="title" idx="102" hasCustomPrompt="1"/>
+            <p:ph idx="102" type="title" hasCustomPrompt="1"/>
           </p:nvPr>
         </p:nvSpPr>
         <p:spPr>
@@ -1092,7 +1330,7 @@
         <p:txBody>
           <a:bodyPr wrap="square" rtlCol="0"/>
           <a:lstStyle>
-            <a:lvl1pPr marL="0" indent="0">
+            <a:lvl1pPr indent="0" marL="0">
               <a:buNone/>
               <a:defRPr lang="en-US" sz="2800" b="1" dirty="0">
                 <a:solidFill>
@@ -1102,7 +1340,7 @@
             </a:lvl1pPr>
           </a:lstStyle>
           <a:p>
-            <a:pPr marL="0" indent="0">
+            <a:pPr indent="0" marL="0">
               <a:buNone/>
             </a:pPr>
             <a:endParaRPr lang="en-US" sz="2800" dirty="0"/>
@@ -1130,7 +1368,7 @@
           <a:bodyPr wrap="square" lIns="0" tIns="0" rIns="0" bIns="0" rtlCol="0" anchor="ctr"/>
           <a:lstStyle/>
           <a:p>
-            <a:pPr marL="0" indent="0">
+            <a:pPr indent="0" marL="0">
               <a:buNone/>
             </a:pPr>
             <a:r>
@@ -1165,7 +1403,7 @@
           </a:prstGeom>
           <a:extLst>
             <a:ext uri="{C572A759-6A51-4108-AA02-DFA0A04FC94B}">
-              <ma14:wrappingTextBoxFlag xmlns:ma14="http://schemas.microsoft.com/office/mac/drawingml/2011/main" xmlns="" val="0"/>
+              <ma14:wrappingTextBoxFlag xmlns:ma14="http://schemas.microsoft.com/office/mac/drawingml/2011/main" val="0"/>
             </a:ext>
           </a:extLst>
         </p:spPr>
@@ -1183,8 +1421,8 @@
           <a:p>
             <a:pPr algn="l"/>
             <a:fld id="{F7021451-1387-4CA6-816F-3879F97B5CBC}" type="slidenum">
-              <a:rPr lang="en-US" b="0"/>
-              <a:t>‹#›</a:t>
+              <a:rPr b="0" lang="en-US"/>
+              <a:t>1003</a:t>
             </a:fld>
             <a:endParaRPr lang="en-US"/>
           </a:p>
@@ -1201,11 +1439,6 @@
 <file path=ppt/slideMasters/slideMaster1.xml><?xml version="1.0" encoding="utf-8"?>
 <p:sldMaster xmlns:a="http://schemas.openxmlformats.org/drawingml/2006/main" xmlns:r="http://schemas.openxmlformats.org/officeDocument/2006/relationships" xmlns:p="http://schemas.openxmlformats.org/presentationml/2006/main">
   <p:cSld>
-    <p:bg>
-      <p:bgRef idx="1001">
-        <a:schemeClr val="bg1"/>
-      </p:bgRef>
-    </p:bg>
     <p:spTree>
       <p:nvGrpSpPr>
         <p:cNvPr id="1" name=""/>
@@ -1240,7 +1473,7 @@
           </a:prstGeom>
           <a:extLst>
             <a:ext uri="{C572A759-6A51-4108-AA02-DFA0A04FC94B}">
-              <ma14:wrappingTextBoxFlag xmlns:ma14="http://schemas.microsoft.com/office/mac/drawingml/2011/main" xmlns="" val="0"/>
+              <ma14:wrappingTextBoxFlag xmlns:ma14="http://schemas.microsoft.com/office/mac/drawingml/2011/main" val="0"/>
             </a:ext>
           </a:extLst>
         </p:spPr>
@@ -1258,8 +1491,8 @@
           <a:p>
             <a:pPr algn="l"/>
             <a:fld id="{F7021451-1387-4CA6-816F-3879F97B5CBC}" type="slidenum">
-              <a:rPr lang="en-US" b="0"/>
-              <a:t>‹#›</a:t>
+              <a:rPr b="0" lang="en-US"/>
+              <a:t>null</a:t>
             </a:fld>
             <a:endParaRPr lang="en-US"/>
           </a:p>
@@ -1547,11 +1780,9 @@
       <p:sp>
         <p:nvSpPr>
           <p:cNvPr id="2" name="Text 2"/>
-          <p:cNvSpPr>
-            <a:spLocks noGrp="1"/>
-          </p:cNvSpPr>
+          <p:cNvSpPr/>
           <p:nvPr>
-            <p:ph type="title" idx="102" hasCustomPrompt="1"/>
+            <p:ph idx="102" type="title" hasCustomPrompt="1"/>
           </p:nvPr>
         </p:nvSpPr>
         <p:spPr>
@@ -1569,7 +1800,7 @@
           <a:bodyPr wrap="square" rtlCol="0" anchor="t"/>
           <a:lstStyle/>
           <a:p>
-            <a:pPr marL="0" indent="0">
+            <a:pPr indent="0" marL="0">
               <a:buNone/>
             </a:pPr>
             <a:r>
@@ -1587,11 +1818,9 @@
       <p:sp>
         <p:nvSpPr>
           <p:cNvPr id="3" name="Text 2"/>
-          <p:cNvSpPr>
-            <a:spLocks noGrp="1"/>
-          </p:cNvSpPr>
+          <p:cNvSpPr/>
           <p:nvPr>
-            <p:ph type="body" idx="103" hasCustomPrompt="1"/>
+            <p:ph idx="103" type="body" hasCustomPrompt="1"/>
           </p:nvPr>
         </p:nvSpPr>
         <p:spPr>
@@ -1609,7 +1838,7 @@
           <a:bodyPr wrap="square" rtlCol="0" anchor="t"/>
           <a:lstStyle/>
           <a:p>
-            <a:pPr marL="0" indent="0">
+            <a:pPr indent="0" marL="0">
               <a:buNone/>
             </a:pPr>
             <a:r>
@@ -1623,7 +1852,7 @@
             <a:endParaRPr lang="en-US" sz="1600" dirty="0"/>
           </a:p>
           <a:p>
-            <a:pPr marL="0" indent="0">
+            <a:pPr indent="0" marL="0">
               <a:buNone/>
             </a:pPr>
             <a:r>
@@ -1637,7 +1866,7 @@
             <a:endParaRPr lang="en-US" sz="1600" dirty="0"/>
           </a:p>
           <a:p>
-            <a:pPr marL="0" indent="0">
+            <a:pPr indent="0" marL="0">
               <a:buNone/>
             </a:pPr>
             <a:r>
@@ -1680,11 +1909,9 @@
       <p:sp>
         <p:nvSpPr>
           <p:cNvPr id="2" name="Text 2"/>
-          <p:cNvSpPr>
-            <a:spLocks noGrp="1"/>
-          </p:cNvSpPr>
+          <p:cNvSpPr/>
           <p:nvPr>
-            <p:ph type="title" idx="102" hasCustomPrompt="1"/>
+            <p:ph idx="102" type="title" hasCustomPrompt="1"/>
           </p:nvPr>
         </p:nvSpPr>
         <p:spPr>
@@ -1702,7 +1929,7 @@
           <a:bodyPr wrap="square" rtlCol="0" anchor="ctr"/>
           <a:lstStyle/>
           <a:p>
-            <a:pPr marL="0" indent="0">
+            <a:pPr indent="0" marL="0">
               <a:buNone/>
             </a:pPr>
             <a:r>
@@ -1783,7 +2010,7 @@
           <a:bodyPr wrap="square" lIns="0" tIns="0" rIns="0" bIns="0" rtlCol="0" anchor="t"/>
           <a:lstStyle/>
           <a:p>
-            <a:pPr marL="0" indent="0">
+            <a:pPr indent="0" marL="0">
               <a:buNone/>
             </a:pPr>
             <a:r>
@@ -1822,7 +2049,7 @@
           <a:bodyPr wrap="square" lIns="0" tIns="0" rIns="0" bIns="0" rtlCol="0" anchor="t"/>
           <a:lstStyle/>
           <a:p>
-            <a:pPr marL="0" indent="0">
+            <a:pPr indent="0" marL="0">
               <a:buNone/>
             </a:pPr>
             <a:r>
@@ -1903,7 +2130,7 @@
           <a:bodyPr wrap="square" lIns="0" tIns="0" rIns="0" bIns="0" rtlCol="0" anchor="t"/>
           <a:lstStyle/>
           <a:p>
-            <a:pPr marL="0" indent="0">
+            <a:pPr indent="0" marL="0">
               <a:buNone/>
             </a:pPr>
             <a:r>
@@ -1942,7 +2169,7 @@
           <a:bodyPr wrap="square" lIns="0" tIns="0" rIns="0" bIns="0" rtlCol="0" anchor="t"/>
           <a:lstStyle/>
           <a:p>
-            <a:pPr marL="0" indent="0">
+            <a:pPr indent="0" marL="0">
               <a:buNone/>
             </a:pPr>
             <a:r>
@@ -2023,7 +2250,7 @@
           <a:bodyPr wrap="square" lIns="0" tIns="0" rIns="0" bIns="0" rtlCol="0" anchor="t"/>
           <a:lstStyle/>
           <a:p>
-            <a:pPr marL="0" indent="0">
+            <a:pPr indent="0" marL="0">
               <a:buNone/>
             </a:pPr>
             <a:r>
@@ -2062,7 +2289,7 @@
           <a:bodyPr wrap="square" lIns="0" tIns="0" rIns="0" bIns="0" rtlCol="0" anchor="t"/>
           <a:lstStyle/>
           <a:p>
-            <a:pPr marL="0" indent="0">
+            <a:pPr indent="0" marL="0">
               <a:buNone/>
             </a:pPr>
             <a:r>
@@ -2143,7 +2370,7 @@
           <a:bodyPr wrap="square" lIns="0" tIns="0" rIns="0" bIns="0" rtlCol="0" anchor="t"/>
           <a:lstStyle/>
           <a:p>
-            <a:pPr marL="0" indent="0">
+            <a:pPr indent="0" marL="0">
               <a:buNone/>
             </a:pPr>
             <a:r>
@@ -2182,7 +2409,7 @@
           <a:bodyPr wrap="square" lIns="0" tIns="0" rIns="0" bIns="0" rtlCol="0" anchor="t"/>
           <a:lstStyle/>
           <a:p>
-            <a:pPr marL="0" indent="0">
+            <a:pPr indent="0" marL="0">
               <a:buNone/>
             </a:pPr>
             <a:r>
@@ -2263,7 +2490,7 @@
           <a:bodyPr wrap="square" lIns="0" tIns="0" rIns="0" bIns="0" rtlCol="0" anchor="t"/>
           <a:lstStyle/>
           <a:p>
-            <a:pPr marL="0" indent="0">
+            <a:pPr indent="0" marL="0">
               <a:buNone/>
             </a:pPr>
             <a:r>
@@ -2302,7 +2529,7 @@
           <a:bodyPr wrap="square" lIns="0" tIns="0" rIns="0" bIns="0" rtlCol="0" anchor="t"/>
           <a:lstStyle/>
           <a:p>
-            <a:pPr marL="0" indent="0">
+            <a:pPr indent="0" marL="0">
               <a:buNone/>
             </a:pPr>
             <a:r>
@@ -2338,7 +2565,7 @@
           <a:bodyPr wrap="square" lIns="0" tIns="0" rIns="0" bIns="0" rtlCol="0" anchor="t"/>
           <a:lstStyle/>
           <a:p>
-            <a:pPr marL="0" indent="0">
+            <a:pPr indent="0" marL="0">
               <a:buNone/>
             </a:pPr>
             <a:r>
@@ -2373,7 +2600,7 @@
           </a:prstGeom>
           <a:extLst>
             <a:ext uri="{C572A759-6A51-4108-AA02-DFA0A04FC94B}">
-              <ma14:wrappingTextBoxFlag xmlns:ma14="http://schemas.microsoft.com/office/mac/drawingml/2011/main" xmlns="" val="0"/>
+              <ma14:wrappingTextBoxFlag xmlns:ma14="http://schemas.microsoft.com/office/mac/drawingml/2011/main" val="0"/>
             </a:ext>
           </a:extLst>
         </p:spPr>
@@ -2391,7 +2618,7 @@
           <a:p>
             <a:pPr algn="l"/>
             <a:fld id="{F7021451-1387-4CA6-816F-3879F97B5CBC}" type="slidenum">
-              <a:rPr lang="en-US" b="0"/>
+              <a:rPr b="0" lang="en-US"/>
               <a:t>2</a:t>
             </a:fld>
             <a:endParaRPr lang="en-US"/>
@@ -2426,11 +2653,9 @@
       <p:sp>
         <p:nvSpPr>
           <p:cNvPr id="2" name="Text 2"/>
-          <p:cNvSpPr>
-            <a:spLocks noGrp="1"/>
-          </p:cNvSpPr>
+          <p:cNvSpPr/>
           <p:nvPr>
-            <p:ph type="title" idx="102" hasCustomPrompt="1"/>
+            <p:ph idx="102" type="title" hasCustomPrompt="1"/>
           </p:nvPr>
         </p:nvSpPr>
         <p:spPr>
@@ -2448,7 +2673,7 @@
           <a:bodyPr wrap="square" rtlCol="0" anchor="ctr"/>
           <a:lstStyle/>
           <a:p>
-            <a:pPr marL="0" indent="0">
+            <a:pPr indent="0" marL="0">
               <a:buNone/>
             </a:pPr>
             <a:r>
@@ -2509,7 +2734,7 @@
           <a:bodyPr wrap="square" lIns="0" tIns="0" rIns="0" bIns="0" rtlCol="0" anchor="t"/>
           <a:lstStyle/>
           <a:p>
-            <a:pPr marL="0" indent="0">
+            <a:pPr indent="0" marL="0">
               <a:buNone/>
             </a:pPr>
             <a:r>
@@ -2548,7 +2773,7 @@
           <a:bodyPr wrap="square" lIns="0" tIns="0" rIns="0" bIns="0" rtlCol="0" anchor="t"/>
           <a:lstStyle/>
           <a:p>
-            <a:pPr marL="0" indent="0">
+            <a:pPr indent="0" marL="0">
               <a:buNone/>
             </a:pPr>
             <a:r>
@@ -2609,7 +2834,7 @@
           <a:bodyPr wrap="square" lIns="0" tIns="0" rIns="0" bIns="0" rtlCol="0" anchor="t"/>
           <a:lstStyle/>
           <a:p>
-            <a:pPr marL="0" indent="0">
+            <a:pPr indent="0" marL="0">
               <a:buNone/>
             </a:pPr>
             <a:r>
@@ -2670,7 +2895,7 @@
           <a:bodyPr wrap="square" lIns="0" tIns="0" rIns="0" bIns="0" rtlCol="0" anchor="t"/>
           <a:lstStyle/>
           <a:p>
-            <a:pPr marL="0" indent="0">
+            <a:pPr indent="0" marL="0">
               <a:buNone/>
             </a:pPr>
             <a:r>
@@ -2709,7 +2934,7 @@
           <a:bodyPr wrap="square" lIns="0" tIns="0" rIns="0" bIns="0" rtlCol="0" anchor="t"/>
           <a:lstStyle/>
           <a:p>
-            <a:pPr marL="0" indent="0">
+            <a:pPr indent="0" marL="0">
               <a:buNone/>
             </a:pPr>
             <a:r>
@@ -2770,7 +2995,7 @@
           <a:bodyPr wrap="square" lIns="0" tIns="0" rIns="0" bIns="0" rtlCol="0" anchor="t"/>
           <a:lstStyle/>
           <a:p>
-            <a:pPr marL="0" indent="0">
+            <a:pPr indent="0" marL="0">
               <a:buNone/>
             </a:pPr>
             <a:r>
@@ -2784,7 +3009,7 @@
             <a:endParaRPr lang="en-US" sz="1050" dirty="0"/>
           </a:p>
           <a:p>
-            <a:pPr marL="0" indent="0">
+            <a:pPr indent="0" marL="0">
               <a:buNone/>
             </a:pPr>
             <a:r>
@@ -2845,7 +3070,7 @@
           <a:bodyPr wrap="square" lIns="0" tIns="0" rIns="0" bIns="0" rtlCol="0" anchor="t"/>
           <a:lstStyle/>
           <a:p>
-            <a:pPr marL="0" indent="0">
+            <a:pPr indent="0" marL="0">
               <a:buNone/>
             </a:pPr>
             <a:r>
@@ -2884,7 +3109,7 @@
           <a:bodyPr wrap="square" lIns="0" tIns="0" rIns="0" bIns="0" rtlCol="0" anchor="t"/>
           <a:lstStyle/>
           <a:p>
-            <a:pPr marL="0" indent="0">
+            <a:pPr indent="0" marL="0">
               <a:buNone/>
             </a:pPr>
             <a:r>
@@ -2945,7 +3170,7 @@
           <a:bodyPr wrap="square" lIns="0" tIns="0" rIns="0" bIns="0" rtlCol="0" anchor="t"/>
           <a:lstStyle/>
           <a:p>
-            <a:pPr marL="0" indent="0">
+            <a:pPr indent="0" marL="0">
               <a:buNone/>
             </a:pPr>
             <a:r>
@@ -2980,7 +3205,7 @@
           </a:prstGeom>
           <a:extLst>
             <a:ext uri="{C572A759-6A51-4108-AA02-DFA0A04FC94B}">
-              <ma14:wrappingTextBoxFlag xmlns:ma14="http://schemas.microsoft.com/office/mac/drawingml/2011/main" xmlns="" val="0"/>
+              <ma14:wrappingTextBoxFlag xmlns:ma14="http://schemas.microsoft.com/office/mac/drawingml/2011/main" val="0"/>
             </a:ext>
           </a:extLst>
         </p:spPr>
@@ -2998,7 +3223,7 @@
           <a:p>
             <a:pPr algn="l"/>
             <a:fld id="{F7021451-1387-4CA6-816F-3879F97B5CBC}" type="slidenum">
-              <a:rPr lang="en-US" b="0"/>
+              <a:rPr b="0" lang="en-US"/>
               <a:t>3</a:t>
             </a:fld>
             <a:endParaRPr lang="en-US"/>
@@ -3033,11 +3258,9 @@
       <p:sp>
         <p:nvSpPr>
           <p:cNvPr id="2" name="Text 2"/>
-          <p:cNvSpPr>
-            <a:spLocks noGrp="1"/>
-          </p:cNvSpPr>
+          <p:cNvSpPr/>
           <p:nvPr>
-            <p:ph type="title" idx="102" hasCustomPrompt="1"/>
+            <p:ph idx="102" type="title" hasCustomPrompt="1"/>
           </p:nvPr>
         </p:nvSpPr>
         <p:spPr>
@@ -3055,7 +3278,7 @@
           <a:bodyPr wrap="square" rtlCol="0" anchor="ctr"/>
           <a:lstStyle/>
           <a:p>
-            <a:pPr marL="0" indent="0">
+            <a:pPr indent="0" marL="0">
               <a:buNone/>
             </a:pPr>
             <a:r>
@@ -3271,7 +3494,7 @@
           <a:bodyPr wrap="square" lIns="0" tIns="0" rIns="0" bIns="0" rtlCol="0" anchor="t"/>
           <a:lstStyle/>
           <a:p>
-            <a:pPr marL="0" indent="0">
+            <a:pPr indent="0" marL="0">
               <a:buNone/>
             </a:pPr>
             <a:r>
@@ -3310,7 +3533,7 @@
           <a:bodyPr wrap="square" lIns="0" tIns="0" rIns="0" bIns="0" rtlCol="0" anchor="t"/>
           <a:lstStyle/>
           <a:p>
-            <a:pPr marL="0" indent="0">
+            <a:pPr indent="0" marL="0">
               <a:buNone/>
             </a:pPr>
             <a:r>
@@ -3346,7 +3569,7 @@
           <a:bodyPr wrap="square" lIns="0" tIns="0" rIns="0" bIns="0" rtlCol="0" anchor="t"/>
           <a:lstStyle/>
           <a:p>
-            <a:pPr marL="0" indent="0">
+            <a:pPr indent="0" marL="0">
               <a:buNone/>
             </a:pPr>
             <a:r>
@@ -3402,7 +3625,7 @@
           <a:bodyPr wrap="square" lIns="0" tIns="0" rIns="0" bIns="0" rtlCol="0" anchor="t"/>
           <a:lstStyle/>
           <a:p>
-            <a:pPr marL="0" indent="0">
+            <a:pPr indent="0" marL="0">
               <a:buNone/>
             </a:pPr>
             <a:r>
@@ -3437,7 +3660,7 @@
           </a:prstGeom>
           <a:extLst>
             <a:ext uri="{C572A759-6A51-4108-AA02-DFA0A04FC94B}">
-              <ma14:wrappingTextBoxFlag xmlns:ma14="http://schemas.microsoft.com/office/mac/drawingml/2011/main" xmlns="" val="0"/>
+              <ma14:wrappingTextBoxFlag xmlns:ma14="http://schemas.microsoft.com/office/mac/drawingml/2011/main" val="0"/>
             </a:ext>
           </a:extLst>
         </p:spPr>
@@ -3455,7 +3678,7 @@
           <a:p>
             <a:pPr algn="l"/>
             <a:fld id="{F7021451-1387-4CA6-816F-3879F97B5CBC}" type="slidenum">
-              <a:rPr lang="en-US" b="0"/>
+              <a:rPr b="0" lang="en-US"/>
               <a:t>4</a:t>
             </a:fld>
             <a:endParaRPr lang="en-US"/>
@@ -3490,11 +3713,9 @@
       <p:sp>
         <p:nvSpPr>
           <p:cNvPr id="2" name="Text 2"/>
-          <p:cNvSpPr>
-            <a:spLocks noGrp="1"/>
-          </p:cNvSpPr>
+          <p:cNvSpPr/>
           <p:nvPr>
-            <p:ph type="title" idx="102" hasCustomPrompt="1"/>
+            <p:ph idx="102" type="title" hasCustomPrompt="1"/>
           </p:nvPr>
         </p:nvSpPr>
         <p:spPr>
@@ -3512,7 +3733,7 @@
           <a:bodyPr wrap="square" rtlCol="0" anchor="ctr"/>
           <a:lstStyle/>
           <a:p>
-            <a:pPr marL="0" indent="0">
+            <a:pPr indent="0" marL="0">
               <a:buNone/>
             </a:pPr>
             <a:r>
@@ -3550,27 +3771,9 @@
             <a:tbl>
               <a:tblPr/>
               <a:tblGrid>
-                <a:gridCol w="1463040">
-                  <a:extLst>
-                    <a:ext uri="{9D8B030D-6E8A-4147-A177-3AD203B41FA5}">
-                      <a16:colId xmlns:a16="http://schemas.microsoft.com/office/drawing/2014/main" val="20000"/>
-                    </a:ext>
-                  </a:extLst>
-                </a:gridCol>
-                <a:gridCol w="2926080">
-                  <a:extLst>
-                    <a:ext uri="{9D8B030D-6E8A-4147-A177-3AD203B41FA5}">
-                      <a16:colId xmlns:a16="http://schemas.microsoft.com/office/drawing/2014/main" val="20001"/>
-                    </a:ext>
-                  </a:extLst>
-                </a:gridCol>
-                <a:gridCol w="3657600">
-                  <a:extLst>
-                    <a:ext uri="{9D8B030D-6E8A-4147-A177-3AD203B41FA5}">
-                      <a16:colId xmlns:a16="http://schemas.microsoft.com/office/drawing/2014/main" val="20002"/>
-                    </a:ext>
-                  </a:extLst>
-                </a:gridCol>
+                <a:gridCol w="1463040"/>
+                <a:gridCol w="2926080"/>
+                <a:gridCol w="3657600"/>
               </a:tblGrid>
               <a:tr h="502920">
                 <a:tc>
@@ -3578,7 +3781,7 @@
                     <a:bodyPr/>
                     <a:lstStyle/>
                     <a:p>
-                      <a:pPr marL="0" indent="0">
+                      <a:pPr indent="0" marL="0">
                         <a:buNone/>
                       </a:pPr>
                       <a:endParaRPr lang="en-US" sz="1300" dirty="0"/>
@@ -3631,7 +3834,7 @@
                     <a:bodyPr/>
                     <a:lstStyle/>
                     <a:p>
-                      <a:pPr marL="0" indent="0">
+                      <a:pPr indent="0" marL="0">
                         <a:buNone/>
                       </a:pPr>
                       <a:r>
@@ -3692,7 +3895,7 @@
                     <a:bodyPr/>
                     <a:lstStyle/>
                     <a:p>
-                      <a:pPr marL="0" indent="0">
+                      <a:pPr indent="0" marL="0">
                         <a:buNone/>
                       </a:pPr>
                       <a:r>
@@ -3748,11 +3951,6 @@
                     </a:solidFill>
                   </a:tcPr>
                 </a:tc>
-                <a:extLst>
-                  <a:ext uri="{0D108BD9-81ED-4DB2-BD59-A6C34878D82A}">
-                    <a16:rowId xmlns:a16="http://schemas.microsoft.com/office/drawing/2014/main" val="10000"/>
-                  </a:ext>
-                </a:extLst>
               </a:tr>
               <a:tr h="502920">
                 <a:tc>
@@ -3760,7 +3958,7 @@
                     <a:bodyPr/>
                     <a:lstStyle/>
                     <a:p>
-                      <a:pPr marL="0" indent="0">
+                      <a:pPr indent="0" marL="0">
                         <a:buNone/>
                       </a:pPr>
                       <a:r>
@@ -3821,7 +4019,7 @@
                     <a:bodyPr/>
                     <a:lstStyle/>
                     <a:p>
-                      <a:pPr marL="0" indent="0">
+                      <a:pPr indent="0" marL="0">
                         <a:buNone/>
                       </a:pPr>
                       <a:r>
@@ -3882,7 +4080,7 @@
                     <a:bodyPr/>
                     <a:lstStyle/>
                     <a:p>
-                      <a:pPr marL="0" indent="0">
+                      <a:pPr indent="0" marL="0">
                         <a:buNone/>
                       </a:pPr>
                       <a:r>
@@ -3938,11 +4136,6 @@
                     </a:solidFill>
                   </a:tcPr>
                 </a:tc>
-                <a:extLst>
-                  <a:ext uri="{0D108BD9-81ED-4DB2-BD59-A6C34878D82A}">
-                    <a16:rowId xmlns:a16="http://schemas.microsoft.com/office/drawing/2014/main" val="10001"/>
-                  </a:ext>
-                </a:extLst>
               </a:tr>
               <a:tr h="502920">
                 <a:tc>
@@ -3950,7 +4143,7 @@
                     <a:bodyPr/>
                     <a:lstStyle/>
                     <a:p>
-                      <a:pPr marL="0" indent="0">
+                      <a:pPr indent="0" marL="0">
                         <a:buNone/>
                       </a:pPr>
                       <a:r>
@@ -4011,7 +4204,7 @@
                     <a:bodyPr/>
                     <a:lstStyle/>
                     <a:p>
-                      <a:pPr marL="0" indent="0">
+                      <a:pPr indent="0" marL="0">
                         <a:buNone/>
                       </a:pPr>
                       <a:r>
@@ -4072,7 +4265,7 @@
                     <a:bodyPr/>
                     <a:lstStyle/>
                     <a:p>
-                      <a:pPr marL="0" indent="0">
+                      <a:pPr indent="0" marL="0">
                         <a:buNone/>
                       </a:pPr>
                       <a:r>
@@ -4128,11 +4321,6 @@
                     </a:solidFill>
                   </a:tcPr>
                 </a:tc>
-                <a:extLst>
-                  <a:ext uri="{0D108BD9-81ED-4DB2-BD59-A6C34878D82A}">
-                    <a16:rowId xmlns:a16="http://schemas.microsoft.com/office/drawing/2014/main" val="10002"/>
-                  </a:ext>
-                </a:extLst>
               </a:tr>
               <a:tr h="502920">
                 <a:tc>
@@ -4140,7 +4328,7 @@
                     <a:bodyPr/>
                     <a:lstStyle/>
                     <a:p>
-                      <a:pPr marL="0" indent="0">
+                      <a:pPr indent="0" marL="0">
                         <a:buNone/>
                       </a:pPr>
                       <a:r>
@@ -4201,7 +4389,7 @@
                     <a:bodyPr/>
                     <a:lstStyle/>
                     <a:p>
-                      <a:pPr marL="0" indent="0">
+                      <a:pPr indent="0" marL="0">
                         <a:buNone/>
                       </a:pPr>
                       <a:r>
@@ -4262,7 +4450,7 @@
                     <a:bodyPr/>
                     <a:lstStyle/>
                     <a:p>
-                      <a:pPr marL="0" indent="0">
+                      <a:pPr indent="0" marL="0">
                         <a:buNone/>
                       </a:pPr>
                       <a:r>
@@ -4318,11 +4506,6 @@
                     </a:solidFill>
                   </a:tcPr>
                 </a:tc>
-                <a:extLst>
-                  <a:ext uri="{0D108BD9-81ED-4DB2-BD59-A6C34878D82A}">
-                    <a16:rowId xmlns:a16="http://schemas.microsoft.com/office/drawing/2014/main" val="10003"/>
-                  </a:ext>
-                </a:extLst>
               </a:tr>
               <a:tr h="502920">
                 <a:tc>
@@ -4330,7 +4513,7 @@
                     <a:bodyPr/>
                     <a:lstStyle/>
                     <a:p>
-                      <a:pPr marL="0" indent="0">
+                      <a:pPr indent="0" marL="0">
                         <a:buNone/>
                       </a:pPr>
                       <a:r>
@@ -4391,7 +4574,7 @@
                     <a:bodyPr/>
                     <a:lstStyle/>
                     <a:p>
-                      <a:pPr marL="0" indent="0">
+                      <a:pPr indent="0" marL="0">
                         <a:buNone/>
                       </a:pPr>
                       <a:r>
@@ -4452,7 +4635,7 @@
                     <a:bodyPr/>
                     <a:lstStyle/>
                     <a:p>
-                      <a:pPr marL="0" indent="0">
+                      <a:pPr indent="0" marL="0">
                         <a:buNone/>
                       </a:pPr>
                       <a:r>
@@ -4508,11 +4691,6 @@
                     </a:solidFill>
                   </a:tcPr>
                 </a:tc>
-                <a:extLst>
-                  <a:ext uri="{0D108BD9-81ED-4DB2-BD59-A6C34878D82A}">
-                    <a16:rowId xmlns:a16="http://schemas.microsoft.com/office/drawing/2014/main" val="10004"/>
-                  </a:ext>
-                </a:extLst>
               </a:tr>
               <a:tr h="502920">
                 <a:tc>
@@ -4520,7 +4698,7 @@
                     <a:bodyPr/>
                     <a:lstStyle/>
                     <a:p>
-                      <a:pPr marL="0" indent="0">
+                      <a:pPr indent="0" marL="0">
                         <a:buNone/>
                       </a:pPr>
                       <a:r>
@@ -4581,7 +4759,7 @@
                     <a:bodyPr/>
                     <a:lstStyle/>
                     <a:p>
-                      <a:pPr marL="0" indent="0">
+                      <a:pPr indent="0" marL="0">
                         <a:buNone/>
                       </a:pPr>
                       <a:r>
@@ -4642,7 +4820,7 @@
                     <a:bodyPr/>
                     <a:lstStyle/>
                     <a:p>
-                      <a:pPr marL="0" indent="0">
+                      <a:pPr indent="0" marL="0">
                         <a:buNone/>
                       </a:pPr>
                       <a:r>
@@ -4698,11 +4876,6 @@
                     </a:solidFill>
                   </a:tcPr>
                 </a:tc>
-                <a:extLst>
-                  <a:ext uri="{0D108BD9-81ED-4DB2-BD59-A6C34878D82A}">
-                    <a16:rowId xmlns:a16="http://schemas.microsoft.com/office/drawing/2014/main" val="10005"/>
-                  </a:ext>
-                </a:extLst>
               </a:tr>
             </a:tbl>
           </a:graphicData>
@@ -4729,7 +4902,7 @@
           <a:bodyPr wrap="square" lIns="0" tIns="0" rIns="0" bIns="0" rtlCol="0" anchor="t"/>
           <a:lstStyle/>
           <a:p>
-            <a:pPr marL="0" indent="0">
+            <a:pPr indent="0" marL="0">
               <a:buNone/>
             </a:pPr>
             <a:r>
@@ -4764,7 +4937,7 @@
           </a:prstGeom>
           <a:extLst>
             <a:ext uri="{C572A759-6A51-4108-AA02-DFA0A04FC94B}">
-              <ma14:wrappingTextBoxFlag xmlns:ma14="http://schemas.microsoft.com/office/mac/drawingml/2011/main" xmlns="" val="0"/>
+              <ma14:wrappingTextBoxFlag xmlns:ma14="http://schemas.microsoft.com/office/mac/drawingml/2011/main" val="0"/>
             </a:ext>
           </a:extLst>
         </p:spPr>
@@ -4782,7 +4955,7 @@
           <a:p>
             <a:pPr algn="l"/>
             <a:fld id="{F7021451-1387-4CA6-816F-3879F97B5CBC}" type="slidenum">
-              <a:rPr lang="en-US" b="0"/>
+              <a:rPr b="0" lang="en-US"/>
               <a:t>5</a:t>
             </a:fld>
             <a:endParaRPr lang="en-US"/>
@@ -4817,11 +4990,9 @@
       <p:sp>
         <p:nvSpPr>
           <p:cNvPr id="2" name="Text 2"/>
-          <p:cNvSpPr>
-            <a:spLocks noGrp="1"/>
-          </p:cNvSpPr>
+          <p:cNvSpPr/>
           <p:nvPr>
-            <p:ph type="title" idx="102" hasCustomPrompt="1"/>
+            <p:ph idx="102" type="title" hasCustomPrompt="1"/>
           </p:nvPr>
         </p:nvSpPr>
         <p:spPr>
@@ -4839,7 +5010,7 @@
           <a:bodyPr wrap="square" rtlCol="0" anchor="ctr"/>
           <a:lstStyle/>
           <a:p>
-            <a:pPr marL="0" indent="0">
+            <a:pPr indent="0" marL="0">
               <a:buNone/>
             </a:pPr>
             <a:r>
@@ -4900,7 +5071,7 @@
           <a:bodyPr wrap="square" lIns="0" tIns="0" rIns="0" bIns="0" rtlCol="0" anchor="t"/>
           <a:lstStyle/>
           <a:p>
-            <a:pPr marL="0" indent="0">
+            <a:pPr indent="0" marL="0">
               <a:buNone/>
             </a:pPr>
             <a:r>
@@ -5076,7 +5247,7 @@
           <a:bodyPr wrap="square" lIns="0" tIns="0" rIns="0" bIns="0" rtlCol="0" anchor="t"/>
           <a:lstStyle/>
           <a:p>
-            <a:pPr marL="0" indent="0">
+            <a:pPr indent="0" marL="0">
               <a:buNone/>
             </a:pPr>
             <a:r>
@@ -5088,7 +5259,7 @@
                 <a:ea typeface="Trebuchet MS" pitchFamily="34" charset="-122"/>
                 <a:cs typeface="Trebuchet MS" pitchFamily="34" charset="-120"/>
               </a:rPr>
-              <a:t>What to expect</a:t>
+              <a:t>Results from one run</a:t>
             </a:r>
             <a:endParaRPr lang="en-US" sz="1800" dirty="0"/>
           </a:p>
@@ -5103,7 +5274,7 @@
         <p:spPr>
           <a:xfrm>
             <a:off x="5029200" y="1965960"/>
-            <a:ext cx="3383280" cy="1463040"/>
+            <a:ext cx="3383280" cy="1280160"/>
           </a:xfrm>
           <a:prstGeom prst="rect">
             <a:avLst/>
@@ -5115,55 +5286,55 @@
           <a:bodyPr wrap="square" lIns="0" tIns="0" rIns="0" bIns="0" rtlCol="0" anchor="t"/>
           <a:lstStyle/>
           <a:p>
-            <a:pPr marL="0" indent="0">
+            <a:pPr indent="0" marL="0">
               <a:spcAft>
                 <a:spcPts val="600"/>
               </a:spcAft>
               <a:buNone/>
             </a:pPr>
             <a:r>
-              <a:rPr lang="en-US" sz="1300" dirty="0">
+              <a:rPr lang="en-US" sz="1800" b="1" dirty="0">
                 <a:solidFill>
                   <a:schemeClr val="tx1"/>
                 </a:solidFill>
               </a:rPr>
-              <a:t>Zero-shot: fast, but format varies</a:t>
-            </a:r>
-            <a:endParaRPr lang="en-US" sz="1300" dirty="0"/>
-          </a:p>
-          <a:p>
-            <a:pPr marL="0" indent="0">
+              <a:t>Role-based: 9.66</a:t>
+            </a:r>
+            <a:endParaRPr lang="en-US" sz="1800" dirty="0"/>
+          </a:p>
+          <a:p>
+            <a:pPr indent="0" marL="0">
               <a:spcAft>
                 <a:spcPts val="600"/>
               </a:spcAft>
               <a:buNone/>
             </a:pPr>
             <a:r>
-              <a:rPr lang="en-US" sz="1300" dirty="0">
+              <a:rPr lang="en-US" sz="1800" b="1" dirty="0">
                 <a:solidFill>
                   <a:schemeClr val="tx1"/>
                 </a:solidFill>
               </a:rPr>
-              <a:t>Few-shot: consistent style, depends on examples</a:t>
-            </a:r>
-            <a:endParaRPr lang="en-US" sz="1300" dirty="0"/>
-          </a:p>
-          <a:p>
-            <a:pPr marL="0" indent="0">
+              <a:t>Zero-shot: 9.60</a:t>
+            </a:r>
+            <a:endParaRPr lang="en-US" sz="1800" dirty="0"/>
+          </a:p>
+          <a:p>
+            <a:pPr indent="0" marL="0">
               <a:spcAft>
                 <a:spcPts val="600"/>
               </a:spcAft>
               <a:buNone/>
             </a:pPr>
             <a:r>
-              <a:rPr lang="en-US" sz="1300" dirty="0">
+              <a:rPr lang="en-US" sz="1800" b="1" dirty="0">
                 <a:solidFill>
                   <a:schemeClr val="tx1"/>
                 </a:solidFill>
               </a:rPr>
-              <a:t>Role-based: most grounded, cites sources</a:t>
-            </a:r>
-            <a:endParaRPr lang="en-US" sz="1300" dirty="0"/>
+              <a:t>Few-shot: 9.54</a:t>
+            </a:r>
+            <a:endParaRPr lang="en-US" sz="1800" dirty="0"/>
           </a:p>
         </p:txBody>
       </p:sp>
@@ -5175,8 +5346,8 @@
         </p:nvSpPr>
         <p:spPr>
           <a:xfrm>
-            <a:off x="5029200" y="3520440"/>
-            <a:ext cx="3383280" cy="731520"/>
+            <a:off x="5029200" y="3383280"/>
+            <a:ext cx="3383280" cy="914400"/>
           </a:xfrm>
           <a:prstGeom prst="rect">
             <a:avLst/>
@@ -5188,7 +5359,7 @@
           <a:bodyPr wrap="square" lIns="0" tIns="0" rIns="0" bIns="0" rtlCol="0" anchor="t"/>
           <a:lstStyle/>
           <a:p>
-            <a:pPr marL="0" indent="0">
+            <a:pPr indent="0" marL="0">
               <a:buNone/>
             </a:pPr>
             <a:r>
@@ -5197,7 +5368,7 @@
                   <a:schemeClr val="tx2"/>
                 </a:solidFill>
               </a:rPr>
-              <a:t>Final scores come from the Compare prompts tab and are reported in the written report.</a:t>
+              <a:t>Averages of accuracy, clarity and relevance (out of 10). The gaps are small, so role-based has a slight edge, not a decisive one.</a:t>
             </a:r>
             <a:endParaRPr lang="en-US" sz="1200" dirty="0"/>
           </a:p>
@@ -5223,7 +5394,7 @@
           </a:prstGeom>
           <a:extLst>
             <a:ext uri="{C572A759-6A51-4108-AA02-DFA0A04FC94B}">
-              <ma14:wrappingTextBoxFlag xmlns:ma14="http://schemas.microsoft.com/office/mac/drawingml/2011/main" xmlns="" val="0"/>
+              <ma14:wrappingTextBoxFlag xmlns:ma14="http://schemas.microsoft.com/office/mac/drawingml/2011/main" val="0"/>
             </a:ext>
           </a:extLst>
         </p:spPr>
@@ -5241,7 +5412,7 @@
           <a:p>
             <a:pPr algn="l"/>
             <a:fld id="{F7021451-1387-4CA6-816F-3879F97B5CBC}" type="slidenum">
-              <a:rPr lang="en-US" b="0"/>
+              <a:rPr b="0" lang="en-US"/>
               <a:t>6</a:t>
             </a:fld>
             <a:endParaRPr lang="en-US"/>
@@ -5276,11 +5447,9 @@
       <p:sp>
         <p:nvSpPr>
           <p:cNvPr id="2" name="Text 2"/>
-          <p:cNvSpPr>
-            <a:spLocks noGrp="1"/>
-          </p:cNvSpPr>
+          <p:cNvSpPr/>
           <p:nvPr>
-            <p:ph type="title" idx="102" hasCustomPrompt="1"/>
+            <p:ph idx="102" type="title" hasCustomPrompt="1"/>
           </p:nvPr>
         </p:nvSpPr>
         <p:spPr>
@@ -5298,7 +5467,7 @@
           <a:bodyPr wrap="square" rtlCol="0" anchor="ctr"/>
           <a:lstStyle/>
           <a:p>
-            <a:pPr marL="0" indent="0">
+            <a:pPr indent="0" marL="0">
               <a:buNone/>
             </a:pPr>
             <a:r>
@@ -5359,7 +5528,7 @@
           <a:bodyPr wrap="square" lIns="0" tIns="0" rIns="0" bIns="0" rtlCol="0" anchor="t"/>
           <a:lstStyle/>
           <a:p>
-            <a:pPr marL="0" indent="0">
+            <a:pPr indent="0" marL="0">
               <a:buNone/>
             </a:pPr>
             <a:r>
@@ -5517,7 +5686,7 @@
           <a:bodyPr wrap="square" lIns="0" tIns="0" rIns="0" bIns="0" rtlCol="0" anchor="t"/>
           <a:lstStyle/>
           <a:p>
-            <a:pPr marL="0" indent="0">
+            <a:pPr indent="0" marL="0">
               <a:buNone/>
             </a:pPr>
             <a:r>
@@ -5649,7 +5818,7 @@
           </a:prstGeom>
           <a:extLst>
             <a:ext uri="{C572A759-6A51-4108-AA02-DFA0A04FC94B}">
-              <ma14:wrappingTextBoxFlag xmlns:ma14="http://schemas.microsoft.com/office/mac/drawingml/2011/main" xmlns="" val="0"/>
+              <ma14:wrappingTextBoxFlag xmlns:ma14="http://schemas.microsoft.com/office/mac/drawingml/2011/main" val="0"/>
             </a:ext>
           </a:extLst>
         </p:spPr>
@@ -5667,7 +5836,7 @@
           <a:p>
             <a:pPr algn="l"/>
             <a:fld id="{F7021451-1387-4CA6-816F-3879F97B5CBC}" type="slidenum">
-              <a:rPr lang="en-US" b="0"/>
+              <a:rPr b="0" lang="en-US"/>
               <a:t>7</a:t>
             </a:fld>
             <a:endParaRPr lang="en-US"/>
@@ -5975,265 +6144,4 @@
     </a:ext>
   </a:extLst>
 </a:theme>
-</file>
-
-<file path=ppt/theme/theme2.xml><?xml version="1.0" encoding="utf-8"?>
-<a:theme xmlns:a="http://schemas.openxmlformats.org/drawingml/2006/main" name="Office Theme">
-  <a:themeElements>
-    <a:clrScheme name="Office">
-      <a:dk1>
-        <a:sysClr val="windowText" lastClr="000000"/>
-      </a:dk1>
-      <a:lt1>
-        <a:sysClr val="window" lastClr="FFFFFF"/>
-      </a:lt1>
-      <a:dk2>
-        <a:srgbClr val="44546A"/>
-      </a:dk2>
-      <a:lt2>
-        <a:srgbClr val="E7E6E6"/>
-      </a:lt2>
-      <a:accent1>
-        <a:srgbClr val="5B9BD5"/>
-      </a:accent1>
-      <a:accent2>
-        <a:srgbClr val="ED7D31"/>
-      </a:accent2>
-      <a:accent3>
-        <a:srgbClr val="A5A5A5"/>
-      </a:accent3>
-      <a:accent4>
-        <a:srgbClr val="FFC000"/>
-      </a:accent4>
-      <a:accent5>
-        <a:srgbClr val="4472C4"/>
-      </a:accent5>
-      <a:accent6>
-        <a:srgbClr val="70AD47"/>
-      </a:accent6>
-      <a:hlink>
-        <a:srgbClr val="0563C1"/>
-      </a:hlink>
-      <a:folHlink>
-        <a:srgbClr val="954F72"/>
-      </a:folHlink>
-    </a:clrScheme>
-    <a:fontScheme name="Office">
-      <a:majorFont>
-        <a:latin typeface="Calibri Light" panose="020F0302020204030204"/>
-        <a:ea typeface=""/>
-        <a:cs typeface=""/>
-        <a:font script="Jpan" typeface="游ゴシック Light"/>
-        <a:font script="Hang" typeface="맑은 고딕"/>
-        <a:font script="Hans" typeface="等线 Light"/>
-        <a:font script="Hant" typeface="新細明體"/>
-        <a:font script="Arab" typeface="Times New Roman"/>
-        <a:font script="Hebr" typeface="Times New Roman"/>
-        <a:font script="Thai" typeface="Angsana New"/>
-        <a:font script="Ethi" typeface="Nyala"/>
-        <a:font script="Beng" typeface="Vrinda"/>
-        <a:font script="Gujr" typeface="Shruti"/>
-        <a:font script="Khmr" typeface="MoolBoran"/>
-        <a:font script="Knda" typeface="Tunga"/>
-        <a:font script="Guru" typeface="Raavi"/>
-        <a:font script="Cans" typeface="Euphemia"/>
-        <a:font script="Cher" typeface="Plantagenet Cherokee"/>
-        <a:font script="Yiii" typeface="Microsoft Yi Baiti"/>
-        <a:font script="Tibt" typeface="Microsoft Himalaya"/>
-        <a:font script="Thaa" typeface="MV Boli"/>
-        <a:font script="Deva" typeface="Mangal"/>
-        <a:font script="Telu" typeface="Gautami"/>
-        <a:font script="Taml" typeface="Latha"/>
-        <a:font script="Syrc" typeface="Estrangelo Edessa"/>
-        <a:font script="Orya" typeface="Kalinga"/>
-        <a:font script="Mlym" typeface="Kartika"/>
-        <a:font script="Laoo" typeface="DokChampa"/>
-        <a:font script="Sinh" typeface="Iskoola Pota"/>
-        <a:font script="Mong" typeface="Mongolian Baiti"/>
-        <a:font script="Viet" typeface="Times New Roman"/>
-        <a:font script="Uigh" typeface="Microsoft Uighur"/>
-        <a:font script="Geor" typeface="Sylfaen"/>
-      </a:majorFont>
-      <a:minorFont>
-        <a:latin typeface="Calibri" panose="020F0502020204030204"/>
-        <a:ea typeface=""/>
-        <a:cs typeface=""/>
-        <a:font script="Jpan" typeface="游ゴシック"/>
-        <a:font script="Hang" typeface="맑은 고딕"/>
-        <a:font script="Hans" typeface="等线"/>
-        <a:font script="Hant" typeface="新細明體"/>
-        <a:font script="Arab" typeface="Arial"/>
-        <a:font script="Hebr" typeface="Arial"/>
-        <a:font script="Thai" typeface="Cordia New"/>
-        <a:font script="Ethi" typeface="Nyala"/>
-        <a:font script="Beng" typeface="Vrinda"/>
-        <a:font script="Gujr" typeface="Shruti"/>
-        <a:font script="Khmr" typeface="DaunPenh"/>
-        <a:font script="Knda" typeface="Tunga"/>
-        <a:font script="Guru" typeface="Raavi"/>
-        <a:font script="Cans" typeface="Euphemia"/>
-        <a:font script="Cher" typeface="Plantagenet Cherokee"/>
-        <a:font script="Yiii" typeface="Microsoft Yi Baiti"/>
-        <a:font script="Tibt" typeface="Microsoft Himalaya"/>
-        <a:font script="Thaa" typeface="MV Boli"/>
-        <a:font script="Deva" typeface="Mangal"/>
-        <a:font script="Telu" typeface="Gautami"/>
-        <a:font script="Taml" typeface="Latha"/>
-        <a:font script="Syrc" typeface="Estrangelo Edessa"/>
-        <a:font script="Orya" typeface="Kalinga"/>
-        <a:font script="Mlym" typeface="Kartika"/>
-        <a:font script="Laoo" typeface="DokChampa"/>
-        <a:font script="Sinh" typeface="Iskoola Pota"/>
-        <a:font script="Mong" typeface="Mongolian Baiti"/>
-        <a:font script="Viet" typeface="Arial"/>
-        <a:font script="Uigh" typeface="Microsoft Uighur"/>
-        <a:font script="Geor" typeface="Sylfaen"/>
-      </a:minorFont>
-    </a:fontScheme>
-    <a:fmtScheme name="Office">
-      <a:fillStyleLst>
-        <a:solidFill>
-          <a:schemeClr val="phClr"/>
-        </a:solidFill>
-        <a:gradFill rotWithShape="1">
-          <a:gsLst>
-            <a:gs pos="0">
-              <a:schemeClr val="phClr">
-                <a:lumMod val="110000"/>
-                <a:satMod val="105000"/>
-                <a:tint val="67000"/>
-              </a:schemeClr>
-            </a:gs>
-            <a:gs pos="50000">
-              <a:schemeClr val="phClr">
-                <a:lumMod val="105000"/>
-                <a:satMod val="103000"/>
-                <a:tint val="73000"/>
-              </a:schemeClr>
-            </a:gs>
-            <a:gs pos="100000">
-              <a:schemeClr val="phClr">
-                <a:lumMod val="105000"/>
-                <a:satMod val="109000"/>
-                <a:tint val="81000"/>
-              </a:schemeClr>
-            </a:gs>
-          </a:gsLst>
-          <a:lin ang="5400000" scaled="0"/>
-        </a:gradFill>
-        <a:gradFill rotWithShape="1">
-          <a:gsLst>
-            <a:gs pos="0">
-              <a:schemeClr val="phClr">
-                <a:satMod val="103000"/>
-                <a:lumMod val="102000"/>
-                <a:tint val="94000"/>
-              </a:schemeClr>
-            </a:gs>
-            <a:gs pos="50000">
-              <a:schemeClr val="phClr">
-                <a:satMod val="110000"/>
-                <a:lumMod val="100000"/>
-                <a:shade val="100000"/>
-              </a:schemeClr>
-            </a:gs>
-            <a:gs pos="100000">
-              <a:schemeClr val="phClr">
-                <a:lumMod val="99000"/>
-                <a:satMod val="120000"/>
-                <a:shade val="78000"/>
-              </a:schemeClr>
-            </a:gs>
-          </a:gsLst>
-          <a:lin ang="5400000" scaled="0"/>
-        </a:gradFill>
-      </a:fillStyleLst>
-      <a:lnStyleLst>
-        <a:ln w="6350" cap="flat" cmpd="sng" algn="ctr">
-          <a:solidFill>
-            <a:schemeClr val="phClr"/>
-          </a:solidFill>
-          <a:prstDash val="solid"/>
-          <a:miter lim="800000"/>
-        </a:ln>
-        <a:ln w="12700" cap="flat" cmpd="sng" algn="ctr">
-          <a:solidFill>
-            <a:schemeClr val="phClr"/>
-          </a:solidFill>
-          <a:prstDash val="solid"/>
-          <a:miter lim="800000"/>
-        </a:ln>
-        <a:ln w="19050" cap="flat" cmpd="sng" algn="ctr">
-          <a:solidFill>
-            <a:schemeClr val="phClr"/>
-          </a:solidFill>
-          <a:prstDash val="solid"/>
-          <a:miter lim="800000"/>
-        </a:ln>
-      </a:lnStyleLst>
-      <a:effectStyleLst>
-        <a:effectStyle>
-          <a:effectLst/>
-        </a:effectStyle>
-        <a:effectStyle>
-          <a:effectLst/>
-        </a:effectStyle>
-        <a:effectStyle>
-          <a:effectLst>
-            <a:outerShdw blurRad="57150" dist="19050" dir="5400000" algn="ctr" rotWithShape="0">
-              <a:srgbClr val="000000">
-                <a:alpha val="63000"/>
-              </a:srgbClr>
-            </a:outerShdw>
-          </a:effectLst>
-        </a:effectStyle>
-      </a:effectStyleLst>
-      <a:bgFillStyleLst>
-        <a:solidFill>
-          <a:schemeClr val="phClr"/>
-        </a:solidFill>
-        <a:solidFill>
-          <a:schemeClr val="phClr">
-            <a:tint val="95000"/>
-            <a:satMod val="170000"/>
-          </a:schemeClr>
-        </a:solidFill>
-        <a:gradFill rotWithShape="1">
-          <a:gsLst>
-            <a:gs pos="0">
-              <a:schemeClr val="phClr">
-                <a:tint val="93000"/>
-                <a:satMod val="150000"/>
-                <a:shade val="98000"/>
-                <a:lumMod val="102000"/>
-              </a:schemeClr>
-            </a:gs>
-            <a:gs pos="50000">
-              <a:schemeClr val="phClr">
-                <a:tint val="98000"/>
-                <a:satMod val="130000"/>
-                <a:shade val="90000"/>
-                <a:lumMod val="103000"/>
-              </a:schemeClr>
-            </a:gs>
-            <a:gs pos="100000">
-              <a:schemeClr val="phClr">
-                <a:shade val="63000"/>
-                <a:satMod val="120000"/>
-              </a:schemeClr>
-            </a:gs>
-          </a:gsLst>
-          <a:lin ang="5400000" scaled="0"/>
-        </a:gradFill>
-      </a:bgFillStyleLst>
-    </a:fmtScheme>
-  </a:themeElements>
-  <a:objectDefaults/>
-  <a:extraClrSchemeLst/>
-  <a:extLst>
-    <a:ext uri="{05A4C25C-085E-4340-85A3-A5531E510DB2}">
-      <thm15:themeFamily xmlns:thm15="http://schemas.microsoft.com/office/thememl/2012/main" name="Office Theme" id="{62F939B6-93AF-4DB8-9C6B-D6C7DFDC589F}" vid="{4A3C46E8-61CC-4603-A589-7422A47A8E4A}"/>
-    </a:ext>
-  </a:extLst>
-</a:theme>
 </file>
</xml_diff>